<commit_message>
docs: align submission deck with official India Runs challenge bundle
Reference job_description.docx, candidate_schema.json, redrob_signals_doc,
submission_spec v4, README trap types, and sample_submission.csv caveats.
</commit_message>
<xml_diff>
--- a/docs/RecruitGPT_X_Approach.pptx
+++ b/docs/RecruitGPT_X_Approach.pptx
@@ -3437,18 +3437,18 @@
           <a:lstStyle/>
           <a:p>
             <a:pPr algn="l">
-              <a:defRPr sz="1100" b="0">
+              <a:defRPr sz="1000" b="0">
                 <a:solidFill>
                   <a:srgbClr val="FFFFFF"/>
                 </a:solidFill>
               </a:defRPr>
             </a:pPr>
             <a:r>
-              <a:t>Problem Statement: Build an AI system that ranks 100K candidates the way a recruiter would —</a:t>
+              <a:t>Official bundle: candidates.jsonl (100K) · job_description.docx · redrob_signals_doc.docx · submission_spec v4</a:t>
             </a:r>
             <a:br/>
             <a:r>
-              <a:t>understanding role fit from career context, skills, and behavioral signals, not keyword matching.</a:t>
+              <a:t>Problem: Intelligent Candidate Discovery &amp; Ranking — top-100 shortlist for Senior AI Engineer @ Redrob AI.</a:t>
             </a:r>
           </a:p>
         </p:txBody>
@@ -3692,7 +3692,7 @@
               </a:defRPr>
             </a:pPr>
             <a:r>
-              <a:t>https://github.com/rahulx2001/recruitgpt-x</a:t>
+              <a:t>github.com/rahulx2001/recruitgpt-x</a:t>
             </a:r>
           </a:p>
         </p:txBody>
@@ -3727,7 +3727,7 @@
               </a:defRPr>
             </a:pPr>
             <a:r>
-              <a:t>Full source + README + reproduce script</a:t>
+              <a:t>rank.py + challenge/ + validate_submission.py from bundle</a:t>
             </a:r>
           </a:p>
         </p:txBody>
@@ -3875,7 +3875,7 @@
               </a:defRPr>
             </a:pPr>
             <a:r>
-              <a:t>candidate_id, rank, score, reasoning</a:t>
+              <a:t>submission_spec v4: UTF-8, 100 rows, monotonic scores</a:t>
             </a:r>
           </a:p>
         </p:txBody>
@@ -4023,7 +4023,7 @@
               </a:defRPr>
             </a:pPr>
             <a:r>
-              <a:t>Sample ranking on ≤100 candidates, CPU</a:t>
+              <a:t>§10.5 — sample_candidates.json end-to-end</a:t>
             </a:r>
           </a:p>
         </p:txBody>
@@ -4101,7 +4101,7 @@
               </a:defRPr>
             </a:pPr>
             <a:r>
-              <a:t>Live Demo</a:t>
+              <a:t>Official data</a:t>
             </a:r>
           </a:p>
         </p:txBody>
@@ -4136,7 +4136,7 @@
               </a:defRPr>
             </a:pPr>
             <a:r>
-              <a:t>recruitgpt-x.vercel.app</a:t>
+              <a:t>candidates.jsonl (100K) + job_description.docx</a:t>
             </a:r>
           </a:p>
         </p:txBody>
@@ -4171,7 +4171,7 @@
               </a:defRPr>
             </a:pPr>
             <a:r>
-              <a:t>Recruiter UI — dashboard, analytics, AI chat</a:t>
+              <a:t>Synced via scripts/sync_challenge_data.sh</a:t>
             </a:r>
           </a:p>
         </p:txBody>
@@ -4319,7 +4319,7 @@
               </a:defRPr>
             </a:pPr>
             <a:r>
-              <a:t>Single command → byte-verified submission.csv</a:t>
+              <a:t>CPU ≤5min · 16GB · no network · byte-verified artifact</a:t>
             </a:r>
           </a:p>
         </p:txBody>
@@ -4467,7 +4467,7 @@
               </a:defRPr>
             </a:pPr>
             <a:r>
-              <a:t>Team Schadn · Rahul Kumar Singh · compute + AI declaration</a:t>
+              <a:t>Team Schadn · Rahul Kumar Singh · AI tools declared</a:t>
             </a:r>
           </a:p>
         </p:txBody>
@@ -4892,14 +4892,14 @@
               <a:spcAft>
                 <a:spcPts val="600"/>
               </a:spcAft>
-              <a:defRPr sz="1300">
+              <a:defRPr sz="1200">
                 <a:solidFill>
                   <a:srgbClr val="212121"/>
                 </a:solidFill>
               </a:defRPr>
             </a:pPr>
             <a:r>
-              <a:t>RecruitGPT X offline ranker: scores 100,000 candidates on CPU in ~49–60 seconds.</a:t>
+              <a:t>Rank top 100 from official candidates.jsonl per submission_spec v4 (CSV: candidate_id,rank,score,reasoning).</a:t>
             </a:r>
           </a:p>
           <a:p>
@@ -4907,14 +4907,14 @@
               <a:spcAft>
                 <a:spcPts val="600"/>
               </a:spcAft>
-              <a:defRPr sz="1300">
+              <a:defRPr sz="1200">
                 <a:solidFill>
                   <a:srgbClr val="212121"/>
                 </a:solidFill>
               </a:defRPr>
             </a:pPr>
             <a:r>
-              <a:t>Acts as an AI recruiter — reads title, career narrative, IR skills, availability, and engagement.</a:t>
+              <a:t>Reads full candidate_schema: profile, career_history, skills, redrob_signals (23 fields).</a:t>
             </a:r>
           </a:p>
           <a:p>
@@ -4922,14 +4922,14 @@
               <a:spcAft>
                 <a:spcPts val="600"/>
               </a:spcAft>
-              <a:defRPr sz="1300">
+              <a:defRPr sz="1200">
                 <a:solidFill>
                   <a:srgbClr val="212121"/>
                 </a:solidFill>
               </a:defRPr>
             </a:pPr>
             <a:r>
-              <a:t>Outputs a top-100 shortlist with calibrated scores and 2-sentence grounded reasoning per row.</a:t>
+              <a:t>Hybrid offline ranker on CPU in ~49–60s — meets 5 min / 16GB / no-network constraints.</a:t>
             </a:r>
           </a:p>
           <a:p>
@@ -4937,14 +4937,14 @@
               <a:spcAft>
                 <a:spcPts val="600"/>
               </a:spcAft>
-              <a:defRPr sz="1300">
+              <a:defRPr sz="1200">
                 <a:solidFill>
                   <a:srgbClr val="212121"/>
                 </a:solidFill>
               </a:defRPr>
             </a:pPr>
             <a:r>
-              <a:t>Pre-computed MiniLM bi-encoder + hybrid heuristics — no LLM calls at rank time.</a:t>
+              <a:t>Grounded 2-sentence reasoning per row — matches Stage 4 review criteria in submission_spec.</a:t>
             </a:r>
           </a:p>
         </p:txBody>
@@ -5025,7 +5025,7 @@
               </a:defRPr>
             </a:pPr>
             <a:r>
-              <a:t>Differentiation vs Traditional ATS</a:t>
+              <a:t>Differentiation vs Keyword Matching</a:t>
             </a:r>
           </a:p>
           <a:p>
@@ -5033,14 +5033,14 @@
               <a:spcAft>
                 <a:spcPts val="600"/>
               </a:spcAft>
-              <a:defRPr sz="1300">
+              <a:defRPr sz="1200">
                 <a:solidFill>
                   <a:srgbClr val="212121"/>
                 </a:solidFill>
               </a:defRPr>
             </a:pPr>
             <a:r>
-              <a:t>Keyword ATS: string match → misses semantic fit, ranks honeypot profiles high.</a:t>
+              <a:t>Bundle README warns: keyword stuffers, behavioral twins, ~80 honeypots — we defend all three.</a:t>
             </a:r>
           </a:p>
           <a:p>
@@ -5048,14 +5048,14 @@
               <a:spcAft>
                 <a:spcPts val="600"/>
               </a:spcAft>
-              <a:defRPr sz="1300">
+              <a:defRPr sz="1200">
                 <a:solidFill>
                   <a:srgbClr val="212121"/>
                 </a:solidFill>
               </a:defRPr>
             </a:pPr>
             <a:r>
-              <a:t>Our ranker: career semantics + structural honeypot traps + template-blurb dedup.</a:t>
+              <a:t>Beyond keywords: career semantics + IR skill trust + Redrob behavioral modifier.</a:t>
             </a:r>
           </a:p>
           <a:p>
@@ -5063,14 +5063,14 @@
               <a:spcAft>
                 <a:spcPts val="600"/>
               </a:spcAft>
-              <a:defRPr sz="1300">
+              <a:defRPr sz="1200">
                 <a:solidFill>
                   <a:srgbClr val="212121"/>
                 </a:solidFill>
               </a:defRPr>
             </a:pPr>
             <a:r>
-              <a:t>Availability gate: not open-to-work cannot reach top-10.</a:t>
+              <a:t>Mirrors JD disqualifiers: research-only, consulting-only, CV/speech-only, framework-noise profiles.</a:t>
             </a:r>
           </a:p>
           <a:p>
@@ -5078,14 +5078,14 @@
               <a:spcAft>
                 <a:spcPts val="600"/>
               </a:spcAft>
-              <a:defRPr sz="1300">
+              <a:defRPr sz="1200">
                 <a:solidFill>
                   <a:srgbClr val="212121"/>
                 </a:solidFill>
               </a:defRPr>
             </a:pPr>
             <a:r>
-              <a:t>Explainable: every rank cites real profile facts — no hallucinated employers or skills.</a:t>
+              <a:t>open_to_work_flag=false cannot reach top-10 (per redrob_signals_doc availability logic).</a:t>
             </a:r>
           </a:p>
           <a:p>
@@ -5093,14 +5093,14 @@
               <a:spcAft>
                 <a:spcPts val="600"/>
               </a:spcAft>
-              <a:defRPr sz="1300">
+              <a:defRPr sz="1200">
                 <a:solidFill>
                   <a:srgbClr val="212121"/>
                 </a:solidFill>
               </a:defRPr>
             </a:pPr>
             <a:r>
-              <a:t>Production constraint: CPU-only, offline — scales to 200K+ without per-candidate API cost.</a:t>
+              <a:t>Shipper-first: production-scale CPU ranker, not per-candidate LLM API calls.</a:t>
             </a:r>
           </a:p>
         </p:txBody>
@@ -5231,7 +5231,7 @@
               </a:defRPr>
             </a:pPr>
             <a:r>
-              <a:t>Parsed from job_description.docx → jd_config.py</a:t>
+              <a:t>Official: job_description.docx + candidate_schema.json + redrob_signals_doc.docx</a:t>
             </a:r>
           </a:p>
         </p:txBody>
@@ -5244,8 +5244,8 @@
         </p:nvSpPr>
         <p:spPr>
           <a:xfrm>
-            <a:off x="502920" y="1051560"/>
-            <a:ext cx="4114800" cy="3840480"/>
+            <a:off x="502920" y="1024128"/>
+            <a:ext cx="4114800" cy="1874519"/>
           </a:xfrm>
           <a:prstGeom prst="rect">
             <a:avLst/>
@@ -5269,7 +5269,7 @@
               </a:defRPr>
             </a:pPr>
             <a:r>
-              <a:t>Key JD Requirements</a:t>
+              <a:t>From job_description.docx</a:t>
             </a:r>
           </a:p>
           <a:p>
@@ -5277,14 +5277,14 @@
               <a:spcAft>
                 <a:spcPts val="600"/>
               </a:spcAft>
-              <a:defRPr sz="1300">
+              <a:defRPr sz="1000">
                 <a:solidFill>
                   <a:srgbClr val="212121"/>
                 </a:solidFill>
               </a:defRPr>
             </a:pPr>
             <a:r>
-              <a:t>Role: Senior AI Engineer — retrieval, ranking, embeddings, vector DBs in production.</a:t>
+              <a:t>Role: Senior AI Engineer — Founding Team @ Redrob AI (Series A talent intelligence).</a:t>
             </a:r>
           </a:p>
           <a:p>
@@ -5292,14 +5292,14 @@
               <a:spcAft>
                 <a:spcPts val="600"/>
               </a:spcAft>
-              <a:defRPr sz="1300">
+              <a:defRPr sz="1000">
                 <a:solidFill>
                   <a:srgbClr val="212121"/>
                 </a:solidFill>
               </a:defRPr>
             </a:pPr>
             <a:r>
-              <a:t>Experience: 5–9 years ideal; penalize thin tenure and over-senior outliers.</a:t>
+              <a:t>Location: Pune/Noida preferred; India Tier-1 cities; hybrid work mode.</a:t>
             </a:r>
           </a:p>
           <a:p>
@@ -5307,14 +5307,14 @@
               <a:spcAft>
                 <a:spcPts val="600"/>
               </a:spcAft>
-              <a:defRPr sz="1300">
+              <a:defRPr sz="1000">
                 <a:solidFill>
                   <a:srgbClr val="212121"/>
                 </a:solidFill>
               </a:defRPr>
             </a:pPr>
             <a:r>
-              <a:t>Location: India-based; Pune/Noida preferred in scoring.</a:t>
+              <a:t>Experience: 5–9 years band (flexible if other signals strong).</a:t>
             </a:r>
           </a:p>
           <a:p>
@@ -5322,14 +5322,14 @@
               <a:spcAft>
                 <a:spcPts val="600"/>
               </a:spcAft>
-              <a:defRPr sz="1300">
+              <a:defRPr sz="1000">
                 <a:solidFill>
                   <a:srgbClr val="212121"/>
                 </a:solidFill>
               </a:defRPr>
             </a:pPr>
             <a:r>
-              <a:t>Production language: shipped systems, not research-only or framework demos.</a:t>
+              <a:t>Must-have: production embeddings retrieval, vector DB/hybrid search, Python, ranking eval (NDCG/MRR/MAP).</a:t>
             </a:r>
           </a:p>
           <a:p>
@@ -5337,14 +5337,14 @@
               <a:spcAft>
                 <a:spcPts val="600"/>
               </a:spcAft>
-              <a:defRPr sz="1300">
+              <a:defRPr sz="1000">
                 <a:solidFill>
                   <a:srgbClr val="212121"/>
                 </a:solidFill>
               </a:defRPr>
             </a:pPr>
             <a:r>
-              <a:t>Behavioral modifier from redrob_signals_doc: response rate, recruiter saves, engagement.</a:t>
+              <a:t>JD rejects: pure research-only, LangChain-only AI, consulting-only careers, CV/speech/robotics without IR.</a:t>
             </a:r>
           </a:p>
         </p:txBody>
@@ -5357,8 +5357,8 @@
         </p:nvSpPr>
         <p:spPr>
           <a:xfrm>
-            <a:off x="4754880" y="1051560"/>
-            <a:ext cx="3931920" cy="3840480"/>
+            <a:off x="502920" y="2971800"/>
+            <a:ext cx="4114800" cy="1828800"/>
           </a:xfrm>
           <a:prstGeom prst="rect">
             <a:avLst/>
@@ -5382,7 +5382,7 @@
               </a:defRPr>
             </a:pPr>
             <a:r>
-              <a:t>Candidate Signals We Evaluate</a:t>
+              <a:t>candidate_schema.json fields</a:t>
             </a:r>
           </a:p>
           <a:p>
@@ -5390,14 +5390,14 @@
               <a:spcAft>
                 <a:spcPts val="600"/>
               </a:spcAft>
-              <a:defRPr sz="1300">
+              <a:defRPr sz="1000">
                 <a:solidFill>
                   <a:srgbClr val="212121"/>
                 </a:solidFill>
               </a:defRPr>
             </a:pPr>
             <a:r>
-              <a:t>Title alignment: Rec Sys Engineer, Search Engineer, Senior ML/NLP Engineer.</a:t>
+              <a:t>profile: title, headline, summary, location, years_of_experience, company.</a:t>
             </a:r>
           </a:p>
           <a:p>
@@ -5405,14 +5405,14 @@
               <a:spcAft>
                 <a:spcPts val="600"/>
               </a:spcAft>
-              <a:defRPr sz="1300">
+              <a:defRPr sz="1000">
                 <a:solidFill>
                   <a:srgbClr val="212121"/>
                 </a:solidFill>
               </a:defRPr>
             </a:pPr>
             <a:r>
-              <a:t>Core IR skills: FAISS, Pinecone, Elasticsearch, OpenSearch, Weaviate, retrieval pipelines.</a:t>
+              <a:t>career_history: role descriptions with production IR evidence.</a:t>
             </a:r>
           </a:p>
           <a:p>
@@ -5420,14 +5420,14 @@
               <a:spcAft>
                 <a:spcPts val="600"/>
               </a:spcAft>
-              <a:defRPr sz="1300">
+              <a:defRPr sz="1000">
                 <a:solidFill>
                   <a:srgbClr val="212121"/>
                 </a:solidFill>
               </a:defRPr>
             </a:pPr>
             <a:r>
-              <a:t>Career semantic text: production stories in role descriptions (not keyword stuffing).</a:t>
+              <a:t>skills: proficiency, endorsements, duration_months (trust signal).</a:t>
             </a:r>
           </a:p>
           <a:p>
@@ -5435,14 +5435,52 @@
               <a:spcAft>
                 <a:spcPts val="600"/>
               </a:spcAft>
-              <a:defRPr sz="1300">
+              <a:defRPr sz="1000">
                 <a:solidFill>
                   <a:srgbClr val="212121"/>
                 </a:solidFill>
               </a:defRPr>
             </a:pPr>
             <a:r>
-              <a:t>Skill trust: endorsements, months-used, verified badges — noise skills penalized.</a:t>
+              <a:t>redrob_signals: 23 behavioral fields — modifier on top of skill-match score.</a:t>
+            </a:r>
+          </a:p>
+        </p:txBody>
+      </p:sp>
+      <p:sp>
+        <p:nvSpPr>
+          <p:cNvPr id="7" name="TextBox 6"/>
+          <p:cNvSpPr txBox="1"/>
+          <p:nvPr/>
+        </p:nvSpPr>
+        <p:spPr>
+          <a:xfrm>
+            <a:off x="4709160" y="1024128"/>
+            <a:ext cx="3977639" cy="3794760"/>
+          </a:xfrm>
+          <a:prstGeom prst="rect">
+            <a:avLst/>
+          </a:prstGeom>
+          <a:noFill/>
+        </p:spPr>
+        <p:txBody>
+          <a:bodyPr wrap="square">
+            <a:spAutoFit/>
+          </a:bodyPr>
+          <a:lstStyle/>
+          <a:p>
+            <a:pPr>
+              <a:spcAft>
+                <a:spcPts val="1000"/>
+              </a:spcAft>
+              <a:defRPr sz="2000" b="1">
+                <a:solidFill>
+                  <a:srgbClr val="065A82"/>
+                </a:solidFill>
+              </a:defRPr>
+            </a:pPr>
+            <a:r>
+              <a:t>23 Redrob signals we weight (redrob_signals_doc.docx)</a:t>
             </a:r>
           </a:p>
           <a:p>
@@ -5450,14 +5488,14 @@
               <a:spcAft>
                 <a:spcPts val="600"/>
               </a:spcAft>
-              <a:defRPr sz="1300">
+              <a:defRPr sz="950">
                 <a:solidFill>
                   <a:srgbClr val="212121"/>
                 </a:solidFill>
               </a:defRPr>
             </a:pPr>
             <a:r>
-              <a:t>Availability: open_to_work, notice period (≤30d boosted, 90–120d penalized).</a:t>
+              <a:t>Availability: open_to_work_flag, last_active_date, notice_period_days.</a:t>
             </a:r>
           </a:p>
           <a:p>
@@ -5465,14 +5503,14 @@
               <a:spcAft>
                 <a:spcPts val="600"/>
               </a:spcAft>
-              <a:defRPr sz="1300">
+              <a:defRPr sz="950">
                 <a:solidFill>
                   <a:srgbClr val="212121"/>
                 </a:solidFill>
               </a:defRPr>
             </a:pPr>
             <a:r>
-              <a:t>Engagement: profile views, recruiter saves, interview completion rate.</a:t>
+              <a:t>Responsiveness: recruiter_response_rate, avg_response_time_hours.</a:t>
             </a:r>
           </a:p>
           <a:p>
@@ -5480,14 +5518,74 @@
               <a:spcAft>
                 <a:spcPts val="600"/>
               </a:spcAft>
-              <a:defRPr sz="1300">
+              <a:defRPr sz="950">
                 <a:solidFill>
                   <a:srgbClr val="212121"/>
                 </a:solidFill>
               </a:defRPr>
             </a:pPr>
             <a:r>
-              <a:t>Trap signals: weak title + inflated AI skills, impossible tenure, recycled blurbs.</a:t>
+              <a:t>Engagement: profile_views_received_30d, saved_by_recruiters_30d, search_appearance_30d.</a:t>
+            </a:r>
+          </a:p>
+          <a:p>
+            <a:pPr>
+              <a:spcAft>
+                <a:spcPts val="600"/>
+              </a:spcAft>
+              <a:defRPr sz="950">
+                <a:solidFill>
+                  <a:srgbClr val="212121"/>
+                </a:solidFill>
+              </a:defRPr>
+            </a:pPr>
+            <a:r>
+              <a:t>Assessments: skill_assessment_scores (platform IR tests).</a:t>
+            </a:r>
+          </a:p>
+          <a:p>
+            <a:pPr>
+              <a:spcAft>
+                <a:spcPts val="600"/>
+              </a:spcAft>
+              <a:defRPr sz="950">
+                <a:solidFill>
+                  <a:srgbClr val="212121"/>
+                </a:solidFill>
+              </a:defRPr>
+            </a:pPr>
+            <a:r>
+              <a:t>Activity: github_activity_score, interview_completion_rate, applications_submitted_30d.</a:t>
+            </a:r>
+          </a:p>
+          <a:p>
+            <a:pPr>
+              <a:spcAft>
+                <a:spcPts val="600"/>
+              </a:spcAft>
+              <a:defRPr sz="950">
+                <a:solidFill>
+                  <a:srgbClr val="212121"/>
+                </a:solidFill>
+              </a:defRPr>
+            </a:pPr>
+            <a:r>
+              <a:t>Trust: verified_email, verified_phone, linkedin_connected, profile_completeness_score.</a:t>
+            </a:r>
+          </a:p>
+          <a:p>
+            <a:pPr>
+              <a:spcAft>
+                <a:spcPts val="600"/>
+              </a:spcAft>
+              <a:defRPr sz="950">
+                <a:solidFill>
+                  <a:srgbClr val="212121"/>
+                </a:solidFill>
+              </a:defRPr>
+            </a:pPr>
+            <a:r>
+              <a:t>Plus: willing_to_relocate, preferred_work_mode, expected_salary_range_inr_lpa.</a:t>
             </a:r>
           </a:p>
         </p:txBody>
@@ -5664,14 +5762,14 @@
               <a:spcAft>
                 <a:spcPts val="600"/>
               </a:spcAft>
-              <a:defRPr sz="1200">
+              <a:defRPr sz="1100">
                 <a:solidFill>
                   <a:srgbClr val="212121"/>
                 </a:solidFill>
               </a:defRPr>
             </a:pPr>
             <a:r>
-              <a:t>1. Load candidates.jsonl → build CandidateIndex (title, skills, career, signals).</a:t>
+              <a:t>1. Parse official job_description.docx → jd_config.py + JD embedding.</a:t>
             </a:r>
           </a:p>
           <a:p>
@@ -5679,14 +5777,14 @@
               <a:spcAft>
                 <a:spcPts val="600"/>
               </a:spcAft>
-              <a:defRPr sz="1200">
+              <a:defRPr sz="1100">
                 <a:solidFill>
                   <a:srgbClr val="212121"/>
                 </a:solidFill>
               </a:defRPr>
             </a:pPr>
             <a:r>
-              <a:t>2. Score each candidate with weighted hybrid components + modifiers.</a:t>
+              <a:t>2. Load candidates.jsonl (100K) per bundle README → CandidateIndex.</a:t>
             </a:r>
           </a:p>
           <a:p>
@@ -5694,14 +5792,14 @@
               <a:spcAft>
                 <a:spcPts val="600"/>
               </a:spcAft>
-              <a:defRPr sz="1200">
+              <a:defRPr sz="1100">
                 <a:solidFill>
                   <a:srgbClr val="212121"/>
                 </a:solidFill>
               </a:defRPr>
             </a:pPr>
             <a:r>
-              <a:t>3. Apply honeypot penalty, availability gate, notice modifier, blurb dedup.</a:t>
+              <a:t>3. Score with hybrid v6 + redrob_signals modifier + honeypot traps.</a:t>
             </a:r>
           </a:p>
           <a:p>
@@ -5709,14 +5807,14 @@
               <a:spcAft>
                 <a:spcPts val="600"/>
               </a:spcAft>
-              <a:defRPr sz="1200">
+              <a:defRPr sz="1100">
                 <a:solidFill>
                   <a:srgbClr val="212121"/>
                 </a:solidFill>
               </a:defRPr>
             </a:pPr>
             <a:r>
-              <a:t>4. Calibrate raw scores → sort descending → assign ranks 1–100.</a:t>
+              <a:t>4. Calibrate → sort → ranks 1–100; tie-break candidate_id ascending (spec §3).</a:t>
             </a:r>
           </a:p>
           <a:p>
@@ -5724,14 +5822,14 @@
               <a:spcAft>
                 <a:spcPts val="600"/>
               </a:spcAft>
-              <a:defRPr sz="1200">
+              <a:defRPr sz="1100">
                 <a:solidFill>
                   <a:srgbClr val="212121"/>
                 </a:solidFill>
               </a:defRPr>
             </a:pPr>
             <a:r>
-              <a:t>5. Generate grounded 2-sentence reasoning from score components (no LLM).</a:t>
+              <a:t>5. Write submission.csv per submission_spec v4 — UTF-8, monotonic scores.</a:t>
             </a:r>
           </a:p>
         </p:txBody>
@@ -7679,7 +7777,7 @@
               </a:defRPr>
             </a:pPr>
             <a:r>
-              <a:t>How Rankings Are Explained</a:t>
+              <a:t>Reasoning (submission_spec §3 Stage 4)</a:t>
             </a:r>
           </a:p>
           <a:p>
@@ -7687,14 +7785,14 @@
               <a:spcAft>
                 <a:spcPts val="600"/>
               </a:spcAft>
-              <a:defRPr sz="1200">
+              <a:defRPr sz="1100">
                 <a:solidFill>
                   <a:srgbClr val="212121"/>
                 </a:solidFill>
               </a:defRPr>
             </a:pPr>
             <a:r>
-              <a:t>reasoning column: 2 sentences per candidate in submission.csv.</a:t>
+              <a:t>Format matches spec example: specific facts + JD connection + honest concerns.</a:t>
             </a:r>
           </a:p>
           <a:p>
@@ -7702,14 +7800,14 @@
               <a:spcAft>
                 <a:spcPts val="600"/>
               </a:spcAft>
-              <a:defRPr sz="1200">
+              <a:defRPr sz="1100">
                 <a:solidFill>
                   <a:srgbClr val="212121"/>
                 </a:solidFill>
               </a:defRPr>
             </a:pPr>
             <a:r>
-              <a:t>Sentence 1: specific facts — title, employer, years, location, named IR skills.</a:t>
+              <a:t>Cites only fields present in candidate profile — no hallucinated employers/skills.</a:t>
             </a:r>
           </a:p>
           <a:p>
@@ -7717,14 +7815,14 @@
               <a:spcAft>
                 <a:spcPts val="600"/>
               </a:spcAft>
-              <a:defRPr sz="1200">
+              <a:defRPr sz="1100">
                 <a:solidFill>
                   <a:srgbClr val="212121"/>
                 </a:solidFill>
               </a:defRPr>
             </a:pPr>
             <a:r>
-              <a:t>Sentence 2: JD connection + honest concerns (notice period, thin IR depth, big-tech risk).</a:t>
+              <a:t>Penalties avoided: empty reasoning, identical strings, templated name-swaps.</a:t>
             </a:r>
           </a:p>
           <a:p>
@@ -7732,14 +7830,14 @@
               <a:spcAft>
                 <a:spcPts val="600"/>
               </a:spcAft>
-              <a:defRPr sz="1200">
+              <a:defRPr sz="1100">
                 <a:solidFill>
                   <a:srgbClr val="212121"/>
                 </a:solidFill>
               </a:defRPr>
             </a:pPr>
             <a:r>
-              <a:t>Built from score components — never from an LLM → no hallucinated skills or employers.</a:t>
+              <a:t>Rank tone matches position: strong language at rank 5, honest gaps at rank 95.</a:t>
             </a:r>
           </a:p>
           <a:p>
@@ -7747,29 +7845,14 @@
               <a:spcAft>
                 <a:spcPts val="600"/>
               </a:spcAft>
-              <a:defRPr sz="1200">
+              <a:defRPr sz="1100">
                 <a:solidFill>
                   <a:srgbClr val="212121"/>
                 </a:solidFill>
               </a:defRPr>
             </a:pPr>
             <a:r>
-              <a:t>Stage 4 mock review: 10/10 sampled rows pass all 6 quality checks.</a:t>
-            </a:r>
-          </a:p>
-          <a:p>
-            <a:pPr>
-              <a:spcAft>
-                <a:spcPts val="600"/>
-              </a:spcAft>
-              <a:defRPr sz="1200">
-                <a:solidFill>
-                  <a:srgbClr val="212121"/>
-                </a:solidFill>
-              </a:defRPr>
-            </a:pPr>
-            <a:r>
-              <a:t>100% unique reasoning strings; no empty or copy-paste templates.</a:t>
+              <a:t>Validated: mock_stage4_review.py — 10/10 sampled rows pass 6/6 checks.</a:t>
             </a:r>
           </a:p>
         </p:txBody>
@@ -7807,7 +7890,7 @@
               </a:defRPr>
             </a:pPr>
             <a:r>
-              <a:t>Handling Bad or Suspicious Profiles</a:t>
+              <a:t>Dataset Traps (bundle README + signals doc)</a:t>
             </a:r>
           </a:p>
           <a:p>
@@ -7815,14 +7898,14 @@
               <a:spcAft>
                 <a:spcPts val="600"/>
               </a:spcAft>
-              <a:defRPr sz="1200">
+              <a:defRPr sz="1000">
                 <a:solidFill>
                   <a:srgbClr val="212121"/>
                 </a:solidFill>
               </a:defRPr>
             </a:pPr>
             <a:r>
-              <a:t>Structural honeypots: impossible tenure vs company founding date, expert skills at 0 months.</a:t>
+              <a:t>~80 honeypots: impossible tenure, expert skills at 0 months (tier-0 in ground truth).</a:t>
             </a:r>
           </a:p>
           <a:p>
@@ -7830,14 +7913,14 @@
               <a:spcAft>
                 <a:spcPts val="600"/>
               </a:spcAft>
-              <a:defRPr sz="1200">
+              <a:defRPr sz="1000">
                 <a:solidFill>
                   <a:srgbClr val="212121"/>
                 </a:solidFill>
               </a:defRPr>
             </a:pPr>
             <a:r>
-              <a:t>Title-skill mismatch: HR Manager / Accountant with inflated AI skill lists → heavy demotion.</a:t>
+              <a:t>Keyword stuffers: weak titles (HR Manager, Accountant) + inflated AI skill lists.</a:t>
             </a:r>
           </a:p>
           <a:p>
@@ -7845,14 +7928,14 @@
               <a:spcAft>
                 <a:spcPts val="600"/>
               </a:spcAft>
-              <a:defRPr sz="1200">
+              <a:defRPr sz="1000">
                 <a:solidFill>
                   <a:srgbClr val="212121"/>
                 </a:solidFill>
               </a:defRPr>
             </a:pPr>
             <a:r>
-              <a:t>Template-blurb penalty: recycled career descriptions shared across thousands of profiles.</a:t>
+              <a:t>Behavioral twins: same profile, different redrob_signals — availability wins.</a:t>
             </a:r>
           </a:p>
           <a:p>
@@ -7860,14 +7943,14 @@
               <a:spcAft>
                 <a:spcPts val="600"/>
               </a:spcAft>
-              <a:defRPr sz="1200">
+              <a:defRPr sz="1000">
                 <a:solidFill>
                   <a:srgbClr val="212121"/>
                 </a:solidFill>
               </a:defRPr>
             </a:pPr>
             <a:r>
-              <a:t>Noise skills penalized: HTML, Tailwind, generic frameworks without IR depth.</a:t>
+              <a:t>Template blurbs: recycled career descriptions across thousands of profiles.</a:t>
             </a:r>
           </a:p>
           <a:p>
@@ -7875,14 +7958,14 @@
               <a:spcAft>
                 <a:spcPts val="600"/>
               </a:spcAft>
-              <a:defRPr sz="1200">
+              <a:defRPr sz="1000">
                 <a:solidFill>
                   <a:srgbClr val="212121"/>
                 </a:solidFill>
               </a:defRPr>
             </a:pPr>
             <a:r>
-              <a:t>Availability hard gate: open_to_work=false capped out of top-10.</a:t>
+              <a:t>sample_submission.csv is format-only (ranks honeypots) — not quality reference.</a:t>
             </a:r>
           </a:p>
           <a:p>
@@ -7890,14 +7973,14 @@
               <a:spcAft>
                 <a:spcPts val="600"/>
               </a:spcAft>
-              <a:defRPr sz="1200">
+              <a:defRPr sz="1000">
                 <a:solidFill>
                   <a:srgbClr val="212121"/>
                 </a:solidFill>
               </a:defRPr>
             </a:pPr>
             <a:r>
-              <a:t>Result: 0 structural honeypots in our top-100 submission (0% vs 10% disqualify threshold).</a:t>
+              <a:t>Our result: 0 structural honeypots in top-100 (spec disqualifies &gt;10%).</a:t>
             </a:r>
           </a:p>
         </p:txBody>

</xml_diff>